<commit_message>
Deployed 2dc568d with MkDocs version: 1.5.3
</commit_message>
<xml_diff>
--- a/slides/Week11_Recap.pptx
+++ b/slides/Week11_Recap.pptx
@@ -191,7 +191,7 @@
 <file path=ppt/revisionInfo.xml><?xml version="1.0" encoding="utf-8"?>
 <p1510:revInfo xmlns:a="http://schemas.openxmlformats.org/drawingml/2006/main" xmlns:r="http://schemas.openxmlformats.org/officeDocument/2006/relationships" xmlns:p1510="http://schemas.microsoft.com/office/powerpoint/2015/10/main">
   <p1510:revLst>
-    <p1510:client id="{D7EC3A52-1BE2-4ED5-ADC5-50902A0D9296}" v="1" dt="2026-04-06T06:54:13.843"/>
+    <p1510:client id="{D7EC3A52-1BE2-4ED5-ADC5-50902A0D9296}" v="31" dt="2026-04-07T04:01:35.645"/>
   </p1510:revLst>
 </p1510:revInfo>
 </file>
@@ -200,23 +200,61 @@
 <pc:chgInfo xmlns:a="http://schemas.openxmlformats.org/drawingml/2006/main" xmlns:r="http://schemas.openxmlformats.org/officeDocument/2006/relationships" xmlns:ac="http://schemas.microsoft.com/office/drawing/2013/main/command" xmlns:pc="http://schemas.microsoft.com/office/powerpoint/2013/main/command">
   <pc:docChgLst>
     <pc:chgData name="Zhao Jin" userId="cd05a825-544c-438a-9ba1-08e63db50b47" providerId="ADAL" clId="{5DF3A229-1965-414E-AF54-F4C37AC7DF68}"/>
-    <pc:docChg chg="modSld">
-      <pc:chgData name="Zhao Jin" userId="cd05a825-544c-438a-9ba1-08e63db50b47" providerId="ADAL" clId="{5DF3A229-1965-414E-AF54-F4C37AC7DF68}" dt="2026-04-06T06:54:13.843" v="0" actId="20577"/>
+    <pc:docChg chg="undo custSel modSld">
+      <pc:chgData name="Zhao Jin" userId="cd05a825-544c-438a-9ba1-08e63db50b47" providerId="ADAL" clId="{5DF3A229-1965-414E-AF54-F4C37AC7DF68}" dt="2026-04-07T04:01:41.691" v="52" actId="1076"/>
       <pc:docMkLst>
         <pc:docMk/>
       </pc:docMkLst>
-      <pc:sldChg chg="modSp">
-        <pc:chgData name="Zhao Jin" userId="cd05a825-544c-438a-9ba1-08e63db50b47" providerId="ADAL" clId="{5DF3A229-1965-414E-AF54-F4C37AC7DF68}" dt="2026-04-06T06:54:13.843" v="0" actId="20577"/>
+      <pc:sldChg chg="modSp mod">
+        <pc:chgData name="Zhao Jin" userId="cd05a825-544c-438a-9ba1-08e63db50b47" providerId="ADAL" clId="{5DF3A229-1965-414E-AF54-F4C37AC7DF68}" dt="2026-04-07T04:00:00.896" v="19"/>
         <pc:sldMkLst>
           <pc:docMk/>
           <pc:sldMk cId="3056023935" sldId="596"/>
         </pc:sldMkLst>
+        <pc:spChg chg="mod">
+          <ac:chgData name="Zhao Jin" userId="cd05a825-544c-438a-9ba1-08e63db50b47" providerId="ADAL" clId="{5DF3A229-1965-414E-AF54-F4C37AC7DF68}" dt="2026-04-07T04:00:00.896" v="19"/>
+          <ac:spMkLst>
+            <pc:docMk/>
+            <pc:sldMk cId="3056023935" sldId="596"/>
+            <ac:spMk id="8" creationId="{99A0CDBB-C985-4D72-9121-5ED2A6FEB14D}"/>
+          </ac:spMkLst>
+        </pc:spChg>
         <pc:spChg chg="mod">
           <ac:chgData name="Zhao Jin" userId="cd05a825-544c-438a-9ba1-08e63db50b47" providerId="ADAL" clId="{5DF3A229-1965-414E-AF54-F4C37AC7DF68}" dt="2026-04-06T06:54:13.843" v="0" actId="20577"/>
           <ac:spMkLst>
             <pc:docMk/>
             <pc:sldMk cId="3056023935" sldId="596"/>
             <ac:spMk id="10" creationId="{46782AF2-AA4A-4243-84D2-A48349DF920C}"/>
+          </ac:spMkLst>
+        </pc:spChg>
+      </pc:sldChg>
+      <pc:sldChg chg="modSp mod modAnim">
+        <pc:chgData name="Zhao Jin" userId="cd05a825-544c-438a-9ba1-08e63db50b47" providerId="ADAL" clId="{5DF3A229-1965-414E-AF54-F4C37AC7DF68}" dt="2026-04-07T04:00:20.543" v="21"/>
+        <pc:sldMkLst>
+          <pc:docMk/>
+          <pc:sldMk cId="3047898109" sldId="605"/>
+        </pc:sldMkLst>
+        <pc:spChg chg="mod">
+          <ac:chgData name="Zhao Jin" userId="cd05a825-544c-438a-9ba1-08e63db50b47" providerId="ADAL" clId="{5DF3A229-1965-414E-AF54-F4C37AC7DF68}" dt="2026-04-07T03:59:30.555" v="3" actId="313"/>
+          <ac:spMkLst>
+            <pc:docMk/>
+            <pc:sldMk cId="3047898109" sldId="605"/>
+            <ac:spMk id="6" creationId="{B6757F58-AE25-465B-8055-66D4DA5A865B}"/>
+          </ac:spMkLst>
+        </pc:spChg>
+      </pc:sldChg>
+      <pc:sldChg chg="modSp mod">
+        <pc:chgData name="Zhao Jin" userId="cd05a825-544c-438a-9ba1-08e63db50b47" providerId="ADAL" clId="{5DF3A229-1965-414E-AF54-F4C37AC7DF68}" dt="2026-04-07T04:01:41.691" v="52" actId="1076"/>
+        <pc:sldMkLst>
+          <pc:docMk/>
+          <pc:sldMk cId="4089006062" sldId="642"/>
+        </pc:sldMkLst>
+        <pc:spChg chg="mod">
+          <ac:chgData name="Zhao Jin" userId="cd05a825-544c-438a-9ba1-08e63db50b47" providerId="ADAL" clId="{5DF3A229-1965-414E-AF54-F4C37AC7DF68}" dt="2026-04-07T04:01:41.691" v="52" actId="1076"/>
+          <ac:spMkLst>
+            <pc:docMk/>
+            <pc:sldMk cId="4089006062" sldId="642"/>
+            <ac:spMk id="13" creationId="{BF2076FD-ABA9-4E41-A999-DDB821DA1735}"/>
           </ac:spMkLst>
         </pc:spChg>
       </pc:sldChg>
@@ -837,7 +875,7 @@
               <a:pPr>
                 <a:defRPr/>
               </a:pPr>
-              <a:t>4/6/2026</a:t>
+              <a:t>4/7/2026</a:t>
             </a:fld>
             <a:endParaRPr lang="en-US"/>
           </a:p>
@@ -7245,7 +7283,7 @@
           <a:lstStyle/>
           <a:p>
             <a:r>
-              <a:rPr lang="en-US"/>
+              <a:rPr lang="en-US" dirty="0"/>
               <a:t>{'d', 'g', 'c', 'h', 'b', 'e', 'a', 'f'}</a:t>
             </a:r>
           </a:p>
@@ -7312,21 +7350,21 @@
               <a:buSzPct val="100000"/>
             </a:pPr>
             <a:r>
-              <a:rPr lang="en-GB"/>
+              <a:rPr lang="en-GB" dirty="0"/>
               <a:t>There cannot be repeated positions </a:t>
             </a:r>
             <a:br>
-              <a:rPr lang="en-GB"/>
+              <a:rPr lang="en-GB" dirty="0"/>
             </a:br>
             <a:r>
-              <a:rPr lang="en-GB"/>
+              <a:rPr lang="en-GB" dirty="0"/>
               <a:t>since two queens cannot be in the </a:t>
             </a:r>
             <a:br>
-              <a:rPr lang="en-GB"/>
+              <a:rPr lang="en-GB" dirty="0"/>
             </a:br>
             <a:r>
-              <a:rPr lang="en-GB"/>
+              <a:rPr lang="en-GB" dirty="0"/>
               <a:t>same column.</a:t>
             </a:r>
           </a:p>
@@ -8490,8 +8528,8 @@
         </p:nvSpPr>
         <p:spPr>
           <a:xfrm>
-            <a:off x="6116738" y="3868542"/>
-            <a:ext cx="3006524" cy="1477328"/>
+            <a:off x="4589662" y="5199729"/>
+            <a:ext cx="4325738" cy="1477328"/>
           </a:xfrm>
           <a:prstGeom prst="rect">
             <a:avLst/>
@@ -8538,11 +8576,203 @@
             </a:pPr>
             <a:r>
               <a:rPr lang="en-US" dirty="0">
-                <a:latin typeface="Calibri" panose="020F0502020204030204" pitchFamily="34" charset="0"/>
+                <a:latin typeface="+mj-lt"/>
                 <a:ea typeface="Calibri" panose="020F0502020204030204" pitchFamily="34" charset="0"/>
                 <a:cs typeface="Calibri" panose="020F0502020204030204" pitchFamily="34" charset="0"/>
               </a:rPr>
-              <a:t>queens = {a, b, c, d, e, f, g, h}</a:t>
+              <a:t>queens = {</a:t>
+            </a:r>
+            <a:r>
+              <a:rPr lang="en-US" dirty="0"/>
+              <a:t>'</a:t>
+            </a:r>
+            <a:r>
+              <a:rPr lang="en-US" dirty="0">
+                <a:latin typeface="+mj-lt"/>
+                <a:ea typeface="Calibri" panose="020F0502020204030204" pitchFamily="34" charset="0"/>
+                <a:cs typeface="Calibri" panose="020F0502020204030204" pitchFamily="34" charset="0"/>
+              </a:rPr>
+              <a:t>a</a:t>
+            </a:r>
+            <a:r>
+              <a:rPr lang="en-US" dirty="0"/>
+              <a:t>'</a:t>
+            </a:r>
+            <a:r>
+              <a:rPr lang="en-US" dirty="0">
+                <a:latin typeface="+mj-lt"/>
+                <a:ea typeface="Calibri" panose="020F0502020204030204" pitchFamily="34" charset="0"/>
+                <a:cs typeface="Calibri" panose="020F0502020204030204" pitchFamily="34" charset="0"/>
+              </a:rPr>
+              <a:t>, </a:t>
+            </a:r>
+            <a:r>
+              <a:rPr lang="en-US" dirty="0"/>
+              <a:t>'</a:t>
+            </a:r>
+            <a:r>
+              <a:rPr lang="en-US" dirty="0">
+                <a:latin typeface="+mj-lt"/>
+                <a:ea typeface="Calibri" panose="020F0502020204030204" pitchFamily="34" charset="0"/>
+                <a:cs typeface="Calibri" panose="020F0502020204030204" pitchFamily="34" charset="0"/>
+              </a:rPr>
+              <a:t>b</a:t>
+            </a:r>
+            <a:r>
+              <a:rPr lang="en-US" dirty="0"/>
+              <a:t>'</a:t>
+            </a:r>
+            <a:r>
+              <a:rPr lang="en-US" dirty="0">
+                <a:latin typeface="+mj-lt"/>
+                <a:ea typeface="Calibri" panose="020F0502020204030204" pitchFamily="34" charset="0"/>
+                <a:cs typeface="Calibri" panose="020F0502020204030204" pitchFamily="34" charset="0"/>
+              </a:rPr>
+              <a:t>, </a:t>
+            </a:r>
+            <a:r>
+              <a:rPr lang="en-US" dirty="0"/>
+              <a:t>'</a:t>
+            </a:r>
+            <a:r>
+              <a:rPr lang="en-US" dirty="0">
+                <a:latin typeface="+mj-lt"/>
+                <a:ea typeface="Calibri" panose="020F0502020204030204" pitchFamily="34" charset="0"/>
+                <a:cs typeface="Calibri" panose="020F0502020204030204" pitchFamily="34" charset="0"/>
+              </a:rPr>
+              <a:t>c</a:t>
+            </a:r>
+            <a:r>
+              <a:rPr lang="en-US" dirty="0"/>
+              <a:t>'</a:t>
+            </a:r>
+            <a:r>
+              <a:rPr lang="en-US" dirty="0">
+                <a:latin typeface="+mj-lt"/>
+                <a:ea typeface="Calibri" panose="020F0502020204030204" pitchFamily="34" charset="0"/>
+                <a:cs typeface="Calibri" panose="020F0502020204030204" pitchFamily="34" charset="0"/>
+              </a:rPr>
+              <a:t>, </a:t>
+            </a:r>
+            <a:r>
+              <a:rPr lang="en-US" dirty="0"/>
+              <a:t>'</a:t>
+            </a:r>
+            <a:r>
+              <a:rPr lang="en-US" dirty="0">
+                <a:latin typeface="+mj-lt"/>
+                <a:ea typeface="Calibri" panose="020F0502020204030204" pitchFamily="34" charset="0"/>
+                <a:cs typeface="Calibri" panose="020F0502020204030204" pitchFamily="34" charset="0"/>
+              </a:rPr>
+              <a:t>d</a:t>
+            </a:r>
+            <a:r>
+              <a:rPr lang="en-US" dirty="0"/>
+              <a:t>'</a:t>
+            </a:r>
+            <a:r>
+              <a:rPr lang="en-US" dirty="0">
+                <a:latin typeface="+mj-lt"/>
+                <a:ea typeface="Calibri" panose="020F0502020204030204" pitchFamily="34" charset="0"/>
+                <a:cs typeface="Calibri" panose="020F0502020204030204" pitchFamily="34" charset="0"/>
+              </a:rPr>
+              <a:t>, </a:t>
+            </a:r>
+            <a:r>
+              <a:rPr lang="en-US" dirty="0"/>
+              <a:t>'</a:t>
+            </a:r>
+            <a:r>
+              <a:rPr lang="en-US" dirty="0">
+                <a:latin typeface="+mj-lt"/>
+                <a:ea typeface="Calibri" panose="020F0502020204030204" pitchFamily="34" charset="0"/>
+                <a:cs typeface="Calibri" panose="020F0502020204030204" pitchFamily="34" charset="0"/>
+              </a:rPr>
+              <a:t>e</a:t>
+            </a:r>
+            <a:r>
+              <a:rPr lang="en-US" dirty="0"/>
+              <a:t>'</a:t>
+            </a:r>
+            <a:r>
+              <a:rPr lang="en-US" dirty="0">
+                <a:latin typeface="+mj-lt"/>
+                <a:ea typeface="Calibri" panose="020F0502020204030204" pitchFamily="34" charset="0"/>
+                <a:cs typeface="Calibri" panose="020F0502020204030204" pitchFamily="34" charset="0"/>
+              </a:rPr>
+              <a:t>, </a:t>
+            </a:r>
+            <a:r>
+              <a:rPr lang="en-US" dirty="0"/>
+              <a:t>'</a:t>
+            </a:r>
+            <a:r>
+              <a:rPr lang="en-US" dirty="0">
+                <a:latin typeface="+mj-lt"/>
+                <a:ea typeface="Calibri" panose="020F0502020204030204" pitchFamily="34" charset="0"/>
+                <a:cs typeface="Calibri" panose="020F0502020204030204" pitchFamily="34" charset="0"/>
+              </a:rPr>
+              <a:t>f</a:t>
+            </a:r>
+            <a:r>
+              <a:rPr lang="en-US" dirty="0"/>
+              <a:t>'</a:t>
+            </a:r>
+            <a:r>
+              <a:rPr lang="en-US" dirty="0">
+                <a:latin typeface="+mj-lt"/>
+                <a:ea typeface="Calibri" panose="020F0502020204030204" pitchFamily="34" charset="0"/>
+                <a:cs typeface="Calibri" panose="020F0502020204030204" pitchFamily="34" charset="0"/>
+              </a:rPr>
+              <a:t>, </a:t>
+            </a:r>
+            <a:r>
+              <a:rPr lang="en-US" dirty="0"/>
+              <a:t>'</a:t>
+            </a:r>
+            <a:r>
+              <a:rPr lang="en-US" dirty="0">
+                <a:latin typeface="+mj-lt"/>
+                <a:ea typeface="Calibri" panose="020F0502020204030204" pitchFamily="34" charset="0"/>
+                <a:cs typeface="Calibri" panose="020F0502020204030204" pitchFamily="34" charset="0"/>
+              </a:rPr>
+              <a:t>g</a:t>
+            </a:r>
+            <a:r>
+              <a:rPr lang="en-US" dirty="0"/>
+              <a:t>'</a:t>
+            </a:r>
+            <a:r>
+              <a:rPr lang="en-US" dirty="0">
+                <a:latin typeface="+mj-lt"/>
+                <a:ea typeface="Calibri" panose="020F0502020204030204" pitchFamily="34" charset="0"/>
+                <a:cs typeface="Calibri" panose="020F0502020204030204" pitchFamily="34" charset="0"/>
+              </a:rPr>
+              <a:t>, </a:t>
+            </a:r>
+            <a:r>
+              <a:rPr lang="en-US" dirty="0"/>
+              <a:t>'</a:t>
+            </a:r>
+            <a:r>
+              <a:rPr lang="en-US" dirty="0">
+                <a:latin typeface="+mj-lt"/>
+                <a:ea typeface="Calibri" panose="020F0502020204030204" pitchFamily="34" charset="0"/>
+                <a:cs typeface="Calibri" panose="020F0502020204030204" pitchFamily="34" charset="0"/>
+              </a:rPr>
+              <a:t>h</a:t>
+            </a:r>
+            <a:r>
+              <a:rPr lang="en-US" dirty="0"/>
+              <a:t>'</a:t>
+            </a:r>
+            <a:r>
+              <a:rPr lang="en-US" dirty="0">
+                <a:latin typeface="+mj-lt"/>
+                <a:ea typeface="Calibri" panose="020F0502020204030204" pitchFamily="34" charset="0"/>
+                <a:cs typeface="Calibri" panose="020F0502020204030204" pitchFamily="34" charset="0"/>
+              </a:rPr>
+              <a:t>}</a:t>
             </a:r>
           </a:p>
           <a:p>
@@ -8564,11 +8794,37 @@
             <a:r>
               <a:rPr lang="en-US" b="0" i="0" dirty="0">
                 <a:effectLst/>
-                <a:latin typeface="Calibri" panose="020F0502020204030204" pitchFamily="34" charset="0"/>
+                <a:latin typeface="+mj-lt"/>
                 <a:ea typeface="Calibri" panose="020F0502020204030204" pitchFamily="34" charset="0"/>
                 <a:cs typeface="Calibri" panose="020F0502020204030204" pitchFamily="34" charset="0"/>
               </a:rPr>
-              <a:t>Try solutions {a, …}</a:t>
+              <a:t>Try solutions {</a:t>
+            </a:r>
+            <a:r>
+              <a:rPr lang="en-US" dirty="0"/>
+              <a:t>'</a:t>
+            </a:r>
+            <a:r>
+              <a:rPr lang="en-US" b="0" i="0" dirty="0">
+                <a:effectLst/>
+                <a:latin typeface="+mj-lt"/>
+                <a:ea typeface="Calibri" panose="020F0502020204030204" pitchFamily="34" charset="0"/>
+                <a:cs typeface="Calibri" panose="020F0502020204030204" pitchFamily="34" charset="0"/>
+              </a:rPr>
+              <a:t>a</a:t>
+            </a:r>
+            <a:r>
+              <a:rPr lang="en-US" dirty="0"/>
+              <a:t>'</a:t>
+            </a:r>
+            <a:r>
+              <a:rPr lang="en-US" b="0" i="0" dirty="0">
+                <a:effectLst/>
+                <a:latin typeface="+mj-lt"/>
+                <a:ea typeface="Calibri" panose="020F0502020204030204" pitchFamily="34" charset="0"/>
+                <a:cs typeface="Calibri" panose="020F0502020204030204" pitchFamily="34" charset="0"/>
+              </a:rPr>
+              <a:t>, …}</a:t>
             </a:r>
           </a:p>
           <a:p>
@@ -8589,11 +8845,35 @@
             </a:pPr>
             <a:r>
               <a:rPr lang="en-US" dirty="0">
-                <a:latin typeface="Calibri" panose="020F0502020204030204" pitchFamily="34" charset="0"/>
+                <a:latin typeface="+mj-lt"/>
                 <a:ea typeface="Calibri" panose="020F0502020204030204" pitchFamily="34" charset="0"/>
                 <a:cs typeface="Calibri" panose="020F0502020204030204" pitchFamily="34" charset="0"/>
               </a:rPr>
-              <a:t>Try solutions {b, …}</a:t>
+              <a:t>Try solutions {</a:t>
+            </a:r>
+            <a:r>
+              <a:rPr lang="en-US" dirty="0"/>
+              <a:t>'</a:t>
+            </a:r>
+            <a:r>
+              <a:rPr lang="en-US" dirty="0">
+                <a:latin typeface="+mj-lt"/>
+                <a:ea typeface="Calibri" panose="020F0502020204030204" pitchFamily="34" charset="0"/>
+                <a:cs typeface="Calibri" panose="020F0502020204030204" pitchFamily="34" charset="0"/>
+              </a:rPr>
+              <a:t>b</a:t>
+            </a:r>
+            <a:r>
+              <a:rPr lang="en-US" dirty="0"/>
+              <a:t>'</a:t>
+            </a:r>
+            <a:r>
+              <a:rPr lang="en-US" dirty="0">
+                <a:latin typeface="+mj-lt"/>
+                <a:ea typeface="Calibri" panose="020F0502020204030204" pitchFamily="34" charset="0"/>
+                <a:cs typeface="Calibri" panose="020F0502020204030204" pitchFamily="34" charset="0"/>
+              </a:rPr>
+              <a:t>, …}</a:t>
             </a:r>
           </a:p>
           <a:p>
@@ -8614,7 +8894,7 @@
             </a:pPr>
             <a:r>
               <a:rPr lang="en-US" dirty="0">
-                <a:latin typeface="Calibri" panose="020F0502020204030204" pitchFamily="34" charset="0"/>
+                <a:latin typeface="+mj-lt"/>
                 <a:ea typeface="Calibri" panose="020F0502020204030204" pitchFamily="34" charset="0"/>
                 <a:cs typeface="Calibri" panose="020F0502020204030204" pitchFamily="34" charset="0"/>
               </a:rPr>
@@ -8639,11 +8919,35 @@
             </a:pPr>
             <a:r>
               <a:rPr lang="en-US" dirty="0">
-                <a:latin typeface="Calibri" panose="020F0502020204030204" pitchFamily="34" charset="0"/>
+                <a:latin typeface="+mj-lt"/>
                 <a:ea typeface="Calibri" panose="020F0502020204030204" pitchFamily="34" charset="0"/>
                 <a:cs typeface="Calibri" panose="020F0502020204030204" pitchFamily="34" charset="0"/>
               </a:rPr>
-              <a:t>Try solutions {h, …}</a:t>
+              <a:t>Try solutions {</a:t>
+            </a:r>
+            <a:r>
+              <a:rPr lang="en-US" dirty="0"/>
+              <a:t>'</a:t>
+            </a:r>
+            <a:r>
+              <a:rPr lang="en-US" dirty="0">
+                <a:latin typeface="+mj-lt"/>
+                <a:ea typeface="Calibri" panose="020F0502020204030204" pitchFamily="34" charset="0"/>
+                <a:cs typeface="Calibri" panose="020F0502020204030204" pitchFamily="34" charset="0"/>
+              </a:rPr>
+              <a:t>h</a:t>
+            </a:r>
+            <a:r>
+              <a:rPr lang="en-US" dirty="0"/>
+              <a:t>'</a:t>
+            </a:r>
+            <a:r>
+              <a:rPr lang="en-US" dirty="0">
+                <a:latin typeface="+mj-lt"/>
+                <a:ea typeface="Calibri" panose="020F0502020204030204" pitchFamily="34" charset="0"/>
+                <a:cs typeface="Calibri" panose="020F0502020204030204" pitchFamily="34" charset="0"/>
+              </a:rPr>
+              <a:t>, …}</a:t>
             </a:r>
           </a:p>
         </p:txBody>
@@ -16715,7 +17019,7 @@
                   <a:schemeClr val="tx1"/>
                 </a:solidFill>
               </a:rPr>
-              <a:t>countValue</a:t>
+              <a:t>count_occur</a:t>
             </a:r>
             <a:r>
               <a:rPr lang="en-US" sz="1800" dirty="0">
@@ -16748,7 +17052,7 @@
                   <a:schemeClr val="tx1"/>
                 </a:solidFill>
               </a:rPr>
-              <a:t>countValue</a:t>
+              <a:t>count_occur</a:t>
             </a:r>
             <a:r>
               <a:rPr lang="en-US" sz="1800" dirty="0">
@@ -16796,7 +17100,7 @@
                   <a:schemeClr val="tx1"/>
                 </a:solidFill>
               </a:rPr>
-              <a:t>countValue</a:t>
+              <a:t>count_occur</a:t>
             </a:r>
             <a:r>
               <a:rPr lang="en-US" sz="1800" dirty="0">
@@ -16949,7 +17253,7 @@
                             </p:stCondLst>
                             <p:childTnLst>
                               <p:par>
-                                <p:cTn id="5" presetID="9" presetClass="entr" presetSubtype="0" fill="hold" grpId="0" nodeType="clickEffect">
+                                <p:cTn id="5" presetID="1" presetClass="entr" presetSubtype="0" fill="hold" grpId="0" nodeType="clickEffect">
                                   <p:stCondLst>
                                     <p:cond delay="0"/>
                                   </p:stCondLst>
@@ -16962,7 +17266,7 @@
                                           </p:stCondLst>
                                         </p:cTn>
                                         <p:tgtEl>
-                                          <p:spTgt spid="40"/>
+                                          <p:spTgt spid="6"/>
                                         </p:tgtEl>
                                         <p:attrNameLst>
                                           <p:attrName>style.visibility</p:attrName>
@@ -16972,14 +17276,6 @@
                                         <p:strVal val="visible"/>
                                       </p:to>
                                     </p:set>
-                                    <p:animEffect transition="in" filter="dissolve">
-                                      <p:cBhvr>
-                                        <p:cTn id="7" dur="500"/>
-                                        <p:tgtEl>
-                                          <p:spTgt spid="40"/>
-                                        </p:tgtEl>
-                                      </p:cBhvr>
-                                    </p:animEffect>
                                   </p:childTnLst>
                                 </p:cTn>
                               </p:par>
@@ -17011,7 +17307,7 @@
       </p:par>
     </p:tnLst>
     <p:bldLst>
-      <p:bldP spid="40" grpId="0" animBg="1"/>
+      <p:bldP spid="6" grpId="0" animBg="1"/>
     </p:bldLst>
   </p:timing>
 </p:sld>
@@ -19362,8 +19658,8 @@
         </p:nvSpPr>
         <p:spPr>
           <a:xfrm>
-            <a:off x="5288500" y="3675348"/>
-            <a:ext cx="3398300" cy="1477328"/>
+            <a:off x="4286251" y="3675348"/>
+            <a:ext cx="4400550" cy="1477328"/>
           </a:xfrm>
           <a:prstGeom prst="rect">
             <a:avLst/>
@@ -19414,7 +19710,7 @@
                   <a:schemeClr val="tx1"/>
                 </a:solidFill>
               </a:rPr>
-              <a:t>countValue</a:t>
+              <a:t>count_occur</a:t>
             </a:r>
             <a:r>
               <a:rPr lang="en-US" sz="1800" dirty="0">
@@ -19441,12 +19737,20 @@
               </a:rPr>
             </a:br>
             <a:r>
+              <a:rPr lang="en-US" sz="1800" dirty="0" err="1">
+                <a:solidFill>
+                  <a:schemeClr val="tx1"/>
+                </a:solidFill>
+              </a:rPr>
+              <a:t>count_occur_helper</a:t>
+            </a:r>
+            <a:r>
               <a:rPr lang="en-US" sz="1800" dirty="0">
                 <a:solidFill>
                   <a:schemeClr val="tx1"/>
                 </a:solidFill>
               </a:rPr>
-              <a:t>countValue_v2(7, list, 0, 15) </a:t>
+              <a:t>(7, list, 0, 15) </a:t>
             </a:r>
             <a:r>
               <a:rPr lang="en-US" sz="1800" dirty="0">
@@ -19466,12 +19770,20 @@
               </a:rPr>
             </a:br>
             <a:r>
+              <a:rPr lang="en-US" dirty="0" err="1">
+                <a:solidFill>
+                  <a:schemeClr val="tx1"/>
+                </a:solidFill>
+              </a:rPr>
+              <a:t>count_occur_helper</a:t>
+            </a:r>
+            <a:r>
               <a:rPr lang="en-US" sz="1800" dirty="0">
                 <a:solidFill>
                   <a:schemeClr val="tx1"/>
                 </a:solidFill>
               </a:rPr>
-              <a:t>countValue_v2(7, list, 1, 15) </a:t>
+              <a:t>(7, list, 1, 15) </a:t>
             </a:r>
             <a:r>
               <a:rPr lang="en-US" sz="1800" dirty="0">
@@ -19506,12 +19818,20 @@
               </a:rPr>
             </a:br>
             <a:r>
+              <a:rPr lang="en-US" dirty="0" err="1">
+                <a:solidFill>
+                  <a:schemeClr val="tx1"/>
+                </a:solidFill>
+              </a:rPr>
+              <a:t>count_occur_helper</a:t>
+            </a:r>
+            <a:r>
               <a:rPr lang="en-US" sz="1800" dirty="0">
                 <a:solidFill>
                   <a:schemeClr val="tx1"/>
                 </a:solidFill>
               </a:rPr>
-              <a:t>countValue_v2(7, list, 15, 15)</a:t>
+              <a:t>(7, list, 15, 15)</a:t>
             </a:r>
             <a:endParaRPr lang="en-GB" dirty="0">
               <a:solidFill>

</xml_diff>